<commit_message>
Prepara MagaDrop para repositorio publico
</commit_message>
<xml_diff>
--- a/apresentacao/APRESENTACAO_MAGADROP.pptx
+++ b/apresentacao/APRESENTACAO_MAGADROP.pptx
@@ -2,22 +2,22 @@
 <file path=ppt/presentation.xml><?xml version="1.0" encoding="utf-8"?>
 <p:presentation xmlns:p="http://schemas.openxmlformats.org/presentationml/2006/main">
   <p:sldMasterIdLst>
-    <p:sldMasterId xmlns:r="http://schemas.openxmlformats.org/officeDocument/2006/relationships" id="2147483648" r:id="Rd2407a26834640d3"/>
+    <p:sldMasterId xmlns:r="http://schemas.openxmlformats.org/officeDocument/2006/relationships" id="2147483648" r:id="Ree863fd0c55c4297"/>
   </p:sldMasterIdLst>
   <p:notesMasterIdLst>
-    <p:notesMasterId xmlns:r="http://schemas.openxmlformats.org/officeDocument/2006/relationships" r:id="R517eed9d70f644a8"/>
+    <p:notesMasterId xmlns:r="http://schemas.openxmlformats.org/officeDocument/2006/relationships" r:id="R9e7a550cf8f8441d"/>
   </p:notesMasterIdLst>
   <p:sldIdLst>
-    <p:sldId xmlns:r="http://schemas.openxmlformats.org/officeDocument/2006/relationships" id="256" r:id="Rb2d8ad5071394082"/>
-    <p:sldId xmlns:r="http://schemas.openxmlformats.org/officeDocument/2006/relationships" id="257" r:id="Ref8b5a7230464e68"/>
-    <p:sldId xmlns:r="http://schemas.openxmlformats.org/officeDocument/2006/relationships" id="258" r:id="Rc786e5dcda654705"/>
-    <p:sldId xmlns:r="http://schemas.openxmlformats.org/officeDocument/2006/relationships" id="259" r:id="R3362cacd4edc4f77"/>
-    <p:sldId xmlns:r="http://schemas.openxmlformats.org/officeDocument/2006/relationships" id="260" r:id="R607e9af1d68247f9"/>
-    <p:sldId xmlns:r="http://schemas.openxmlformats.org/officeDocument/2006/relationships" id="261" r:id="Rffdefac7d6bb46b7"/>
-    <p:sldId xmlns:r="http://schemas.openxmlformats.org/officeDocument/2006/relationships" id="262" r:id="R029f407f57f544ec"/>
-    <p:sldId xmlns:r="http://schemas.openxmlformats.org/officeDocument/2006/relationships" id="263" r:id="R72571ec9b620402b"/>
-    <p:sldId xmlns:r="http://schemas.openxmlformats.org/officeDocument/2006/relationships" id="264" r:id="R73293c09d5464119"/>
-    <p:sldId xmlns:r="http://schemas.openxmlformats.org/officeDocument/2006/relationships" id="265" r:id="R6a6e92cfe7f243f6"/>
+    <p:sldId xmlns:r="http://schemas.openxmlformats.org/officeDocument/2006/relationships" id="256" r:id="R46478fb2df884e70"/>
+    <p:sldId xmlns:r="http://schemas.openxmlformats.org/officeDocument/2006/relationships" id="257" r:id="R2c437d6b20084b8b"/>
+    <p:sldId xmlns:r="http://schemas.openxmlformats.org/officeDocument/2006/relationships" id="258" r:id="Redecb17169204ca4"/>
+    <p:sldId xmlns:r="http://schemas.openxmlformats.org/officeDocument/2006/relationships" id="259" r:id="R426e6288be2f49fc"/>
+    <p:sldId xmlns:r="http://schemas.openxmlformats.org/officeDocument/2006/relationships" id="260" r:id="R4168343eaded4a4a"/>
+    <p:sldId xmlns:r="http://schemas.openxmlformats.org/officeDocument/2006/relationships" id="261" r:id="R481b80a89d2543c1"/>
+    <p:sldId xmlns:r="http://schemas.openxmlformats.org/officeDocument/2006/relationships" id="262" r:id="R47e257aeb242440f"/>
+    <p:sldId xmlns:r="http://schemas.openxmlformats.org/officeDocument/2006/relationships" id="263" r:id="R8eeb580d54664cd3"/>
+    <p:sldId xmlns:r="http://schemas.openxmlformats.org/officeDocument/2006/relationships" id="264" r:id="R0eb953ca0fc745aa"/>
+    <p:sldId xmlns:r="http://schemas.openxmlformats.org/officeDocument/2006/relationships" id="265" r:id="R968a3b626b374439"/>
   </p:sldIdLst>
   <p:sldSz cx="12192000" cy="6858000"/>
   <p:notesSz cx="6858000" cy="9144000"/>
@@ -521,7 +521,7 @@
           <a:lstStyle xmlns:a="http://schemas.openxmlformats.org/drawingml/2006/main"/>
           <a:p xmlns:a="http://schemas.openxmlformats.org/drawingml/2006/main">
             <a:r>
-              <a:t>Fonte: código e documentação do repositório MagaDrop, consultados em 6 de setembro de 2026.</a:t>
+              <a:t>Fonte: código, documentação e licença MIT do repositório MagaDrop, consultados em 6 de setembro de 2026.</a:t>
             </a:r>
           </a:p>
         </p:txBody>
@@ -871,7 +871,7 @@
           <a:lstStyle xmlns:a="http://schemas.openxmlformats.org/drawingml/2006/main"/>
           <a:p xmlns:a="http://schemas.openxmlformats.org/drawingml/2006/main">
             <a:r>
-              <a:t>Fonte: código e documentação do repositório MagaDrop, consultados em 6 de setembro de 2026. O endereço exibido na captura é apenas um exemplo da rede usada durante a documentação.</a:t>
+              <a:t>Fonte: código e documentação do repositório MagaDrop, consultados em 6 de setembro de 2026. O endereço 192.168.0.10 mostrado na captura é apenas um exemplo ilustrativo de rede local.</a:t>
             </a:r>
           </a:p>
         </p:txBody>
@@ -1149,7 +1149,7 @@
   </p:cSld>
   <p:clrMap bg1="lt1" tx1="dk1" bg2="lt2" tx2="dk2" accent1="accent1" accent2="accent2" accent3="accent3" accent4="accent4" accent5="accent5" accent6="accent6" hlink="hlink" folHlink="folHlink"/>
   <p:sldLayoutIdLst>
-    <p:sldLayoutId xmlns:r="http://schemas.openxmlformats.org/officeDocument/2006/relationships" id="2147483649" r:id="Rc76128ab722f4d01"/>
+    <p:sldLayoutId xmlns:r="http://schemas.openxmlformats.org/officeDocument/2006/relationships" id="2147483649" r:id="R10503d456640428d"/>
   </p:sldLayoutIdLst>
   <p:txStyles>
     <p:titleStyle>
@@ -1757,14 +1757,14 @@
       </p:sp>
       <p:pic>
         <p:nvPicPr>
-          <p:cNvPr id="11" name=""/>
+          <p:cNvPr id="13" name=""/>
           <p:cNvPicPr>
             <a:picLocks xmlns:a="http://schemas.openxmlformats.org/drawingml/2006/main" noChangeAspect="1"/>
           </p:cNvPicPr>
           <p:nvPr/>
         </p:nvPicPr>
         <p:blipFill>
-          <a:blip xmlns:r="http://schemas.openxmlformats.org/officeDocument/2006/relationships" xmlns:a="http://schemas.openxmlformats.org/drawingml/2006/main" r:embed="Radccd154d88b467f"/>
+          <a:blip xmlns:r="http://schemas.openxmlformats.org/officeDocument/2006/relationships" xmlns:a="http://schemas.openxmlformats.org/drawingml/2006/main" r:embed="Rb9daa7a314314a01"/>
           <a:stretch xmlns:a="http://schemas.openxmlformats.org/drawingml/2006/main"/>
         </p:blipFill>
         <p:spPr>
@@ -1811,6 +1811,7 @@
           <a:lstStyle xmlns:a="http://schemas.openxmlformats.org/drawingml/2006/main"/>
           <a:p xmlns:a="http://schemas.openxmlformats.org/drawingml/2006/main">
             <a:pPr algn="l">
+              <a:buNone/>
               <a:defRPr sz="5700" b="1">
                 <a:solidFill>
                   <a:srgbClr val="F8FAFC"/>
@@ -1868,6 +1869,7 @@
           <a:lstStyle xmlns:a="http://schemas.openxmlformats.org/drawingml/2006/main"/>
           <a:p xmlns:a="http://schemas.openxmlformats.org/drawingml/2006/main">
             <a:pPr algn="l">
+              <a:buNone/>
               <a:defRPr sz="2325" b="0">
                 <a:solidFill>
                   <a:srgbClr val="A8B4CC"/>
@@ -1955,6 +1957,7 @@
           <a:lstStyle xmlns:a="http://schemas.openxmlformats.org/drawingml/2006/main"/>
           <a:p xmlns:a="http://schemas.openxmlformats.org/drawingml/2006/main">
             <a:pPr algn="l">
+              <a:buNone/>
               <a:defRPr sz="1650" b="0">
                 <a:solidFill>
                   <a:srgbClr val="F8FAFC"/>
@@ -2012,6 +2015,7 @@
           <a:lstStyle xmlns:a="http://schemas.openxmlformats.org/drawingml/2006/main"/>
           <a:p xmlns:a="http://schemas.openxmlformats.org/drawingml/2006/main">
             <a:pPr algn="l">
+              <a:buNone/>
               <a:defRPr sz="1200" b="0">
                 <a:solidFill>
                   <a:srgbClr val="A8B4CC"/>
@@ -2158,6 +2162,7 @@
           <a:lstStyle xmlns:a="http://schemas.openxmlformats.org/drawingml/2006/main"/>
           <a:p xmlns:a="http://schemas.openxmlformats.org/drawingml/2006/main">
             <a:pPr algn="l">
+              <a:buNone/>
               <a:defRPr sz="1350" b="1">
                 <a:solidFill>
                   <a:srgbClr val="1BB7D1"/>
@@ -2215,6 +2220,7 @@
           <a:lstStyle xmlns:a="http://schemas.openxmlformats.org/drawingml/2006/main"/>
           <a:p xmlns:a="http://schemas.openxmlformats.org/drawingml/2006/main">
             <a:pPr algn="l">
+              <a:buNone/>
               <a:defRPr sz="3300" b="1">
                 <a:solidFill>
                   <a:srgbClr val="F8FAFC"/>
@@ -2272,6 +2278,7 @@
           <a:lstStyle xmlns:a="http://schemas.openxmlformats.org/drawingml/2006/main"/>
           <a:p xmlns:a="http://schemas.openxmlformats.org/drawingml/2006/main">
             <a:pPr algn="l">
+              <a:buNone/>
               <a:defRPr sz="1125" b="1">
                 <a:solidFill>
                   <a:srgbClr val="A8B4CC"/>
@@ -2329,6 +2336,7 @@
           <a:lstStyle xmlns:a="http://schemas.openxmlformats.org/drawingml/2006/main"/>
           <a:p xmlns:a="http://schemas.openxmlformats.org/drawingml/2006/main">
             <a:pPr algn="r">
+              <a:buNone/>
               <a:defRPr sz="1125" b="0">
                 <a:solidFill>
                   <a:srgbClr val="A8B4CC"/>
@@ -2386,6 +2394,7 @@
           <a:lstStyle xmlns:a="http://schemas.openxmlformats.org/drawingml/2006/main"/>
           <a:p xmlns:a="http://schemas.openxmlformats.org/drawingml/2006/main">
             <a:pPr algn="l">
+              <a:buNone/>
               <a:defRPr sz="1350" b="1">
                 <a:solidFill>
                   <a:srgbClr val="39D98A"/>
@@ -2443,6 +2452,7 @@
           <a:lstStyle xmlns:a="http://schemas.openxmlformats.org/drawingml/2006/main"/>
           <a:p xmlns:a="http://schemas.openxmlformats.org/drawingml/2006/main">
             <a:pPr algn="l">
+              <a:buNone/>
               <a:defRPr sz="2250" b="1">
                 <a:solidFill>
                   <a:srgbClr val="F8FAFC"/>
@@ -2500,6 +2510,7 @@
           <a:lstStyle xmlns:a="http://schemas.openxmlformats.org/drawingml/2006/main"/>
           <a:p xmlns:a="http://schemas.openxmlformats.org/drawingml/2006/main">
             <a:pPr algn="l">
+              <a:buNone/>
               <a:defRPr sz="2550" b="1">
                 <a:solidFill>
                   <a:srgbClr val="1BB7D1"/>
@@ -2557,6 +2568,7 @@
           <a:lstStyle xmlns:a="http://schemas.openxmlformats.org/drawingml/2006/main"/>
           <a:p xmlns:a="http://schemas.openxmlformats.org/drawingml/2006/main">
             <a:pPr algn="l">
+              <a:buNone/>
               <a:defRPr sz="1725" b="0">
                 <a:solidFill>
                   <a:srgbClr val="A8B4CC"/>
@@ -2644,6 +2656,7 @@
           <a:lstStyle xmlns:a="http://schemas.openxmlformats.org/drawingml/2006/main"/>
           <a:p xmlns:a="http://schemas.openxmlformats.org/drawingml/2006/main">
             <a:pPr algn="l">
+              <a:buNone/>
               <a:defRPr sz="1350" b="1">
                 <a:solidFill>
                   <a:srgbClr val="B43CFF"/>
@@ -2701,6 +2714,7 @@
           <a:lstStyle xmlns:a="http://schemas.openxmlformats.org/drawingml/2006/main"/>
           <a:p xmlns:a="http://schemas.openxmlformats.org/drawingml/2006/main">
             <a:pPr algn="l">
+              <a:buNone/>
               <a:defRPr sz="2550" b="1">
                 <a:solidFill>
                   <a:srgbClr val="F8FAFC"/>
@@ -2719,7 +2733,7 @@
                 <a:ea typeface="Segoe UI"/>
                 <a:cs typeface="Segoe UI"/>
               </a:rPr>
-              <a:t>GitHub privado</a:t>
+              <a:t>GitHub público</a:t>
             </a:r>
           </a:p>
         </p:txBody>
@@ -2758,6 +2772,7 @@
           <a:lstStyle xmlns:a="http://schemas.openxmlformats.org/drawingml/2006/main"/>
           <a:p xmlns:a="http://schemas.openxmlformats.org/drawingml/2006/main">
             <a:pPr algn="l">
+              <a:buNone/>
               <a:defRPr sz="1875" b="1">
                 <a:solidFill>
                   <a:srgbClr val="1BB7D1"/>
@@ -2776,7 +2791,7 @@
                 <a:ea typeface="Segoe UI"/>
                 <a:cs typeface="Segoe UI"/>
               </a:rPr>
-              <a:t>Settings &gt; Collaborators &gt; Add people</a:t>
+              <a:t>Clone a branch principal</a:t>
             </a:r>
           </a:p>
         </p:txBody>
@@ -2815,6 +2830,7 @@
           <a:lstStyle xmlns:a="http://schemas.openxmlformats.org/drawingml/2006/main"/>
           <a:p xmlns:a="http://schemas.openxmlformats.org/drawingml/2006/main">
             <a:pPr algn="l">
+              <a:buNone/>
               <a:defRPr sz="1650" b="0">
                 <a:solidFill>
                   <a:srgbClr val="A8B4CC"/>
@@ -2833,7 +2849,7 @@
                 <a:ea typeface="Segoe UI"/>
                 <a:cs typeface="Segoe UI"/>
               </a:rPr>
-              <a:t>Depois do convite, o colaborador pode clonar a branch codex/v3-contas-sessoes e propor mudanças.</a:t>
+              <a:t>Crie um fork, faça suas alterações e envie uma pull request. O código usa a licença MIT.</a:t>
             </a:r>
           </a:p>
         </p:txBody>
@@ -2902,6 +2918,7 @@
           <a:lstStyle xmlns:a="http://schemas.openxmlformats.org/drawingml/2006/main"/>
           <a:p xmlns:a="http://schemas.openxmlformats.org/drawingml/2006/main">
             <a:pPr algn="ctr">
+              <a:buNone/>
               <a:defRPr sz="1650" b="1">
                 <a:solidFill>
                   <a:srgbClr val="FBBF24"/>
@@ -3048,6 +3065,7 @@
           <a:lstStyle xmlns:a="http://schemas.openxmlformats.org/drawingml/2006/main"/>
           <a:p xmlns:a="http://schemas.openxmlformats.org/drawingml/2006/main">
             <a:pPr algn="l">
+              <a:buNone/>
               <a:defRPr sz="1350" b="1">
                 <a:solidFill>
                   <a:srgbClr val="1BB7D1"/>
@@ -3105,6 +3123,7 @@
           <a:lstStyle xmlns:a="http://schemas.openxmlformats.org/drawingml/2006/main"/>
           <a:p xmlns:a="http://schemas.openxmlformats.org/drawingml/2006/main">
             <a:pPr algn="l">
+              <a:buNone/>
               <a:defRPr sz="3300" b="1">
                 <a:solidFill>
                   <a:srgbClr val="F8FAFC"/>
@@ -3162,6 +3181,7 @@
           <a:lstStyle xmlns:a="http://schemas.openxmlformats.org/drawingml/2006/main"/>
           <a:p xmlns:a="http://schemas.openxmlformats.org/drawingml/2006/main">
             <a:pPr algn="l">
+              <a:buNone/>
               <a:defRPr sz="1575" b="0">
                 <a:solidFill>
                   <a:srgbClr val="A8B4CC"/>
@@ -3219,6 +3239,7 @@
           <a:lstStyle xmlns:a="http://schemas.openxmlformats.org/drawingml/2006/main"/>
           <a:p xmlns:a="http://schemas.openxmlformats.org/drawingml/2006/main">
             <a:pPr algn="l">
+              <a:buNone/>
               <a:defRPr sz="1125" b="1">
                 <a:solidFill>
                   <a:srgbClr val="A8B4CC"/>
@@ -3276,6 +3297,7 @@
           <a:lstStyle xmlns:a="http://schemas.openxmlformats.org/drawingml/2006/main"/>
           <a:p xmlns:a="http://schemas.openxmlformats.org/drawingml/2006/main">
             <a:pPr algn="r">
+              <a:buNone/>
               <a:defRPr sz="1125" b="0">
                 <a:solidFill>
                   <a:srgbClr val="A8B4CC"/>
@@ -3443,14 +3465,14 @@
       </p:sp>
       <p:pic>
         <p:nvPicPr>
-          <p:cNvPr id="19" name=""/>
+          <p:cNvPr id="21" name=""/>
           <p:cNvPicPr>
             <a:picLocks xmlns:a="http://schemas.openxmlformats.org/drawingml/2006/main" noChangeAspect="1"/>
           </p:cNvPicPr>
           <p:nvPr/>
         </p:nvPicPr>
         <p:blipFill>
-          <a:blip xmlns:r="http://schemas.openxmlformats.org/officeDocument/2006/relationships" xmlns:a="http://schemas.openxmlformats.org/drawingml/2006/main" r:embed="R03b6ece246264f7b"/>
+          <a:blip xmlns:r="http://schemas.openxmlformats.org/officeDocument/2006/relationships" xmlns:a="http://schemas.openxmlformats.org/drawingml/2006/main" r:embed="R77925c5c86094826"/>
           <a:stretch xmlns:a="http://schemas.openxmlformats.org/drawingml/2006/main"/>
         </p:blipFill>
         <p:spPr>
@@ -3499,6 +3521,7 @@
           <a:lstStyle xmlns:a="http://schemas.openxmlformats.org/drawingml/2006/main"/>
           <a:p xmlns:a="http://schemas.openxmlformats.org/drawingml/2006/main">
             <a:pPr algn="l">
+              <a:buNone/>
               <a:defRPr sz="1575" b="1">
                 <a:solidFill>
                   <a:srgbClr val="39D98A"/>
@@ -3645,6 +3668,7 @@
           <a:lstStyle xmlns:a="http://schemas.openxmlformats.org/drawingml/2006/main"/>
           <a:p xmlns:a="http://schemas.openxmlformats.org/drawingml/2006/main">
             <a:pPr algn="l">
+              <a:buNone/>
               <a:defRPr sz="1350" b="1">
                 <a:solidFill>
                   <a:srgbClr val="1BB7D1"/>
@@ -3702,6 +3726,7 @@
           <a:lstStyle xmlns:a="http://schemas.openxmlformats.org/drawingml/2006/main"/>
           <a:p xmlns:a="http://schemas.openxmlformats.org/drawingml/2006/main">
             <a:pPr algn="l">
+              <a:buNone/>
               <a:defRPr sz="3300" b="1">
                 <a:solidFill>
                   <a:srgbClr val="F8FAFC"/>
@@ -3720,7 +3745,7 @@
                 <a:ea typeface="Segoe UI"/>
                 <a:cs typeface="Segoe UI"/>
               </a:rPr>
-              <a:t>O que precisa ser instalado</a:t>
+              <a:t>Instalação necessária</a:t>
             </a:r>
           </a:p>
         </p:txBody>
@@ -3759,6 +3784,7 @@
           <a:lstStyle xmlns:a="http://schemas.openxmlformats.org/drawingml/2006/main"/>
           <a:p xmlns:a="http://schemas.openxmlformats.org/drawingml/2006/main">
             <a:pPr algn="l">
+              <a:buNone/>
               <a:defRPr sz="1125" b="1">
                 <a:solidFill>
                   <a:srgbClr val="A8B4CC"/>
@@ -3816,6 +3842,7 @@
           <a:lstStyle xmlns:a="http://schemas.openxmlformats.org/drawingml/2006/main"/>
           <a:p xmlns:a="http://schemas.openxmlformats.org/drawingml/2006/main">
             <a:pPr algn="r">
+              <a:buNone/>
               <a:defRPr sz="1125" b="0">
                 <a:solidFill>
                   <a:srgbClr val="A8B4CC"/>
@@ -3873,6 +3900,7 @@
           <a:lstStyle xmlns:a="http://schemas.openxmlformats.org/drawingml/2006/main"/>
           <a:p xmlns:a="http://schemas.openxmlformats.org/drawingml/2006/main">
             <a:pPr algn="l">
+              <a:buNone/>
               <a:defRPr sz="1350" b="1">
                 <a:solidFill>
                   <a:srgbClr val="1BB7D1"/>
@@ -3930,6 +3958,7 @@
           <a:lstStyle xmlns:a="http://schemas.openxmlformats.org/drawingml/2006/main"/>
           <a:p xmlns:a="http://schemas.openxmlformats.org/drawingml/2006/main">
             <a:pPr algn="l">
+              <a:buNone/>
               <a:defRPr sz="4350" b="1">
                 <a:solidFill>
                   <a:srgbClr val="F8FAFC"/>
@@ -3987,6 +4016,7 @@
           <a:lstStyle xmlns:a="http://schemas.openxmlformats.org/drawingml/2006/main"/>
           <a:p xmlns:a="http://schemas.openxmlformats.org/drawingml/2006/main">
             <a:pPr algn="l">
+              <a:buNone/>
               <a:defRPr sz="2100" b="1">
                 <a:solidFill>
                   <a:srgbClr val="39D98A"/>
@@ -4044,6 +4074,7 @@
           <a:lstStyle xmlns:a="http://schemas.openxmlformats.org/drawingml/2006/main"/>
           <a:p xmlns:a="http://schemas.openxmlformats.org/drawingml/2006/main">
             <a:pPr algn="l">
+              <a:buNone/>
               <a:defRPr sz="1725" b="0">
                 <a:solidFill>
                   <a:srgbClr val="A8B4CC"/>
@@ -4131,6 +4162,7 @@
           <a:lstStyle xmlns:a="http://schemas.openxmlformats.org/drawingml/2006/main"/>
           <a:p xmlns:a="http://schemas.openxmlformats.org/drawingml/2006/main">
             <a:pPr algn="l">
+              <a:buNone/>
               <a:defRPr sz="1350" b="1">
                 <a:solidFill>
                   <a:srgbClr val="B43CFF"/>
@@ -4330,6 +4362,7 @@
           <a:lstStyle xmlns:a="http://schemas.openxmlformats.org/drawingml/2006/main"/>
           <a:p xmlns:a="http://schemas.openxmlformats.org/drawingml/2006/main">
             <a:pPr algn="l">
+              <a:buNone/>
               <a:defRPr sz="1500" b="1">
                 <a:solidFill>
                   <a:srgbClr val="FBBF24"/>
@@ -4476,6 +4509,7 @@
           <a:lstStyle xmlns:a="http://schemas.openxmlformats.org/drawingml/2006/main"/>
           <a:p xmlns:a="http://schemas.openxmlformats.org/drawingml/2006/main">
             <a:pPr algn="l">
+              <a:buNone/>
               <a:defRPr sz="1350" b="1">
                 <a:solidFill>
                   <a:srgbClr val="1BB7D1"/>
@@ -4533,6 +4567,7 @@
           <a:lstStyle xmlns:a="http://schemas.openxmlformats.org/drawingml/2006/main"/>
           <a:p xmlns:a="http://schemas.openxmlformats.org/drawingml/2006/main">
             <a:pPr algn="l">
+              <a:buNone/>
               <a:defRPr sz="3300" b="1">
                 <a:solidFill>
                   <a:srgbClr val="F8FAFC"/>
@@ -4590,6 +4625,7 @@
           <a:lstStyle xmlns:a="http://schemas.openxmlformats.org/drawingml/2006/main"/>
           <a:p xmlns:a="http://schemas.openxmlformats.org/drawingml/2006/main">
             <a:pPr algn="l">
+              <a:buNone/>
               <a:defRPr sz="1575" b="0">
                 <a:solidFill>
                   <a:srgbClr val="A8B4CC"/>
@@ -4647,6 +4683,7 @@
           <a:lstStyle xmlns:a="http://schemas.openxmlformats.org/drawingml/2006/main"/>
           <a:p xmlns:a="http://schemas.openxmlformats.org/drawingml/2006/main">
             <a:pPr algn="l">
+              <a:buNone/>
               <a:defRPr sz="1125" b="1">
                 <a:solidFill>
                   <a:srgbClr val="A8B4CC"/>
@@ -4704,6 +4741,7 @@
           <a:lstStyle xmlns:a="http://schemas.openxmlformats.org/drawingml/2006/main"/>
           <a:p xmlns:a="http://schemas.openxmlformats.org/drawingml/2006/main">
             <a:pPr algn="r">
+              <a:buNone/>
               <a:defRPr sz="1125" b="0">
                 <a:solidFill>
                   <a:srgbClr val="A8B4CC"/>
@@ -4761,6 +4799,7 @@
           <a:lstStyle xmlns:a="http://schemas.openxmlformats.org/drawingml/2006/main"/>
           <a:p xmlns:a="http://schemas.openxmlformats.org/drawingml/2006/main">
             <a:pPr algn="l">
+              <a:buNone/>
               <a:defRPr sz="3600" b="1">
                 <a:solidFill>
                   <a:srgbClr val="1BB7D1"/>
@@ -4818,6 +4857,7 @@
           <a:lstStyle xmlns:a="http://schemas.openxmlformats.org/drawingml/2006/main"/>
           <a:p xmlns:a="http://schemas.openxmlformats.org/drawingml/2006/main">
             <a:pPr algn="l">
+              <a:buNone/>
               <a:defRPr sz="2175" b="1">
                 <a:solidFill>
                   <a:srgbClr val="F8FAFC"/>
@@ -4875,6 +4915,7 @@
           <a:lstStyle xmlns:a="http://schemas.openxmlformats.org/drawingml/2006/main"/>
           <a:p xmlns:a="http://schemas.openxmlformats.org/drawingml/2006/main">
             <a:pPr algn="l">
+              <a:buNone/>
               <a:defRPr sz="1650" b="0">
                 <a:solidFill>
                   <a:srgbClr val="A8B4CC"/>
@@ -4962,6 +5003,7 @@
           <a:lstStyle xmlns:a="http://schemas.openxmlformats.org/drawingml/2006/main"/>
           <a:p xmlns:a="http://schemas.openxmlformats.org/drawingml/2006/main">
             <a:pPr algn="l">
+              <a:buNone/>
               <a:defRPr sz="3600" b="1">
                 <a:solidFill>
                   <a:srgbClr val="B43CFF"/>
@@ -5019,6 +5061,7 @@
           <a:lstStyle xmlns:a="http://schemas.openxmlformats.org/drawingml/2006/main"/>
           <a:p xmlns:a="http://schemas.openxmlformats.org/drawingml/2006/main">
             <a:pPr algn="l">
+              <a:buNone/>
               <a:defRPr sz="2175" b="1">
                 <a:solidFill>
                   <a:srgbClr val="F8FAFC"/>
@@ -5076,6 +5119,7 @@
           <a:lstStyle xmlns:a="http://schemas.openxmlformats.org/drawingml/2006/main"/>
           <a:p xmlns:a="http://schemas.openxmlformats.org/drawingml/2006/main">
             <a:pPr algn="l">
+              <a:buNone/>
               <a:defRPr sz="1650" b="0">
                 <a:solidFill>
                   <a:srgbClr val="A8B4CC"/>
@@ -5163,6 +5207,7 @@
           <a:lstStyle xmlns:a="http://schemas.openxmlformats.org/drawingml/2006/main"/>
           <a:p xmlns:a="http://schemas.openxmlformats.org/drawingml/2006/main">
             <a:pPr algn="l">
+              <a:buNone/>
               <a:defRPr sz="3600" b="1">
                 <a:solidFill>
                   <a:srgbClr val="1BB7D1"/>
@@ -5220,6 +5265,7 @@
           <a:lstStyle xmlns:a="http://schemas.openxmlformats.org/drawingml/2006/main"/>
           <a:p xmlns:a="http://schemas.openxmlformats.org/drawingml/2006/main">
             <a:pPr algn="l">
+              <a:buNone/>
               <a:defRPr sz="2175" b="1">
                 <a:solidFill>
                   <a:srgbClr val="F8FAFC"/>
@@ -5277,6 +5323,7 @@
           <a:lstStyle xmlns:a="http://schemas.openxmlformats.org/drawingml/2006/main"/>
           <a:p xmlns:a="http://schemas.openxmlformats.org/drawingml/2006/main">
             <a:pPr algn="l">
+              <a:buNone/>
               <a:defRPr sz="1650" b="0">
                 <a:solidFill>
                   <a:srgbClr val="A8B4CC"/>
@@ -5364,6 +5411,7 @@
           <a:lstStyle xmlns:a="http://schemas.openxmlformats.org/drawingml/2006/main"/>
           <a:p xmlns:a="http://schemas.openxmlformats.org/drawingml/2006/main">
             <a:pPr algn="l">
+              <a:buNone/>
               <a:defRPr sz="3600" b="1">
                 <a:solidFill>
                   <a:srgbClr val="B43CFF"/>
@@ -5421,6 +5469,7 @@
           <a:lstStyle xmlns:a="http://schemas.openxmlformats.org/drawingml/2006/main"/>
           <a:p xmlns:a="http://schemas.openxmlformats.org/drawingml/2006/main">
             <a:pPr algn="l">
+              <a:buNone/>
               <a:defRPr sz="2175" b="1">
                 <a:solidFill>
                   <a:srgbClr val="F8FAFC"/>
@@ -5478,6 +5527,7 @@
           <a:lstStyle xmlns:a="http://schemas.openxmlformats.org/drawingml/2006/main"/>
           <a:p xmlns:a="http://schemas.openxmlformats.org/drawingml/2006/main">
             <a:pPr algn="l">
+              <a:buNone/>
               <a:defRPr sz="1650" b="0">
                 <a:solidFill>
                   <a:srgbClr val="A8B4CC"/>
@@ -5565,6 +5615,7 @@
           <a:lstStyle xmlns:a="http://schemas.openxmlformats.org/drawingml/2006/main"/>
           <a:p xmlns:a="http://schemas.openxmlformats.org/drawingml/2006/main">
             <a:pPr algn="ctr">
+              <a:buNone/>
               <a:defRPr sz="1500" b="0">
                 <a:solidFill>
                   <a:srgbClr val="FBBF24"/>
@@ -5711,6 +5762,7 @@
           <a:lstStyle xmlns:a="http://schemas.openxmlformats.org/drawingml/2006/main"/>
           <a:p xmlns:a="http://schemas.openxmlformats.org/drawingml/2006/main">
             <a:pPr algn="l">
+              <a:buNone/>
               <a:defRPr sz="1350" b="1">
                 <a:solidFill>
                   <a:srgbClr val="1BB7D1"/>
@@ -5768,6 +5820,7 @@
           <a:lstStyle xmlns:a="http://schemas.openxmlformats.org/drawingml/2006/main"/>
           <a:p xmlns:a="http://schemas.openxmlformats.org/drawingml/2006/main">
             <a:pPr algn="l">
+              <a:buNone/>
               <a:defRPr sz="3300" b="1">
                 <a:solidFill>
                   <a:srgbClr val="F8FAFC"/>
@@ -5825,6 +5878,7 @@
           <a:lstStyle xmlns:a="http://schemas.openxmlformats.org/drawingml/2006/main"/>
           <a:p xmlns:a="http://schemas.openxmlformats.org/drawingml/2006/main">
             <a:pPr algn="l">
+              <a:buNone/>
               <a:defRPr sz="1575" b="0">
                 <a:solidFill>
                   <a:srgbClr val="A8B4CC"/>
@@ -5882,6 +5936,7 @@
           <a:lstStyle xmlns:a="http://schemas.openxmlformats.org/drawingml/2006/main"/>
           <a:p xmlns:a="http://schemas.openxmlformats.org/drawingml/2006/main">
             <a:pPr algn="l">
+              <a:buNone/>
               <a:defRPr sz="1125" b="1">
                 <a:solidFill>
                   <a:srgbClr val="A8B4CC"/>
@@ -5939,6 +5994,7 @@
           <a:lstStyle xmlns:a="http://schemas.openxmlformats.org/drawingml/2006/main"/>
           <a:p xmlns:a="http://schemas.openxmlformats.org/drawingml/2006/main">
             <a:pPr algn="r">
+              <a:buNone/>
               <a:defRPr sz="1125" b="0">
                 <a:solidFill>
                   <a:srgbClr val="A8B4CC"/>
@@ -5996,6 +6052,7 @@
           <a:lstStyle xmlns:a="http://schemas.openxmlformats.org/drawingml/2006/main"/>
           <a:p xmlns:a="http://schemas.openxmlformats.org/drawingml/2006/main">
             <a:pPr algn="l">
+              <a:buNone/>
               <a:defRPr sz="3150" b="1">
                 <a:solidFill>
                   <a:srgbClr val="1BB7D1"/>
@@ -6053,6 +6110,7 @@
           <a:lstStyle xmlns:a="http://schemas.openxmlformats.org/drawingml/2006/main"/>
           <a:p xmlns:a="http://schemas.openxmlformats.org/drawingml/2006/main">
             <a:pPr algn="l">
+              <a:buNone/>
               <a:defRPr sz="2025" b="1">
                 <a:solidFill>
                   <a:srgbClr val="F8FAFC"/>
@@ -6110,6 +6168,7 @@
           <a:lstStyle xmlns:a="http://schemas.openxmlformats.org/drawingml/2006/main"/>
           <a:p xmlns:a="http://schemas.openxmlformats.org/drawingml/2006/main">
             <a:pPr algn="l">
+              <a:buNone/>
               <a:defRPr sz="1575" b="0">
                 <a:solidFill>
                   <a:srgbClr val="A8B4CC"/>
@@ -6167,6 +6226,7 @@
           <a:lstStyle xmlns:a="http://schemas.openxmlformats.org/drawingml/2006/main"/>
           <a:p xmlns:a="http://schemas.openxmlformats.org/drawingml/2006/main">
             <a:pPr algn="l">
+              <a:buNone/>
               <a:defRPr sz="3150" b="1">
                 <a:solidFill>
                   <a:srgbClr val="1BB7D1"/>
@@ -6224,6 +6284,7 @@
           <a:lstStyle xmlns:a="http://schemas.openxmlformats.org/drawingml/2006/main"/>
           <a:p xmlns:a="http://schemas.openxmlformats.org/drawingml/2006/main">
             <a:pPr algn="l">
+              <a:buNone/>
               <a:defRPr sz="2025" b="1">
                 <a:solidFill>
                   <a:srgbClr val="F8FAFC"/>
@@ -6281,6 +6342,7 @@
           <a:lstStyle xmlns:a="http://schemas.openxmlformats.org/drawingml/2006/main"/>
           <a:p xmlns:a="http://schemas.openxmlformats.org/drawingml/2006/main">
             <a:pPr algn="l">
+              <a:buNone/>
               <a:defRPr sz="1575" b="0">
                 <a:solidFill>
                   <a:srgbClr val="A8B4CC"/>
@@ -6338,6 +6400,7 @@
           <a:lstStyle xmlns:a="http://schemas.openxmlformats.org/drawingml/2006/main"/>
           <a:p xmlns:a="http://schemas.openxmlformats.org/drawingml/2006/main">
             <a:pPr algn="l">
+              <a:buNone/>
               <a:defRPr sz="3150" b="1">
                 <a:solidFill>
                   <a:srgbClr val="1BB7D1"/>
@@ -6395,6 +6458,7 @@
           <a:lstStyle xmlns:a="http://schemas.openxmlformats.org/drawingml/2006/main"/>
           <a:p xmlns:a="http://schemas.openxmlformats.org/drawingml/2006/main">
             <a:pPr algn="l">
+              <a:buNone/>
               <a:defRPr sz="2025" b="1">
                 <a:solidFill>
                   <a:srgbClr val="F8FAFC"/>
@@ -6452,6 +6516,7 @@
           <a:lstStyle xmlns:a="http://schemas.openxmlformats.org/drawingml/2006/main"/>
           <a:p xmlns:a="http://schemas.openxmlformats.org/drawingml/2006/main">
             <a:pPr algn="l">
+              <a:buNone/>
               <a:defRPr sz="1575" b="0">
                 <a:solidFill>
                   <a:srgbClr val="A8B4CC"/>
@@ -6543,6 +6608,7 @@
           <a:lstStyle xmlns:a="http://schemas.openxmlformats.org/drawingml/2006/main"/>
           <a:p xmlns:a="http://schemas.openxmlformats.org/drawingml/2006/main">
             <a:pPr algn="l">
+              <a:buNone/>
               <a:defRPr sz="2175" b="1">
                 <a:solidFill>
                   <a:srgbClr val="F8FAFC"/>
@@ -6600,6 +6666,7 @@
           <a:lstStyle xmlns:a="http://schemas.openxmlformats.org/drawingml/2006/main"/>
           <a:p xmlns:a="http://schemas.openxmlformats.org/drawingml/2006/main">
             <a:pPr algn="l">
+              <a:buNone/>
               <a:defRPr sz="1875" b="1">
                 <a:solidFill>
                   <a:srgbClr val="39D98A"/>
@@ -6657,6 +6724,7 @@
           <a:lstStyle xmlns:a="http://schemas.openxmlformats.org/drawingml/2006/main"/>
           <a:p xmlns:a="http://schemas.openxmlformats.org/drawingml/2006/main">
             <a:pPr algn="l">
+              <a:buNone/>
               <a:defRPr sz="1425" b="0">
                 <a:solidFill>
                   <a:srgbClr val="A8B4CC"/>
@@ -6714,6 +6782,7 @@
           <a:lstStyle xmlns:a="http://schemas.openxmlformats.org/drawingml/2006/main"/>
           <a:p xmlns:a="http://schemas.openxmlformats.org/drawingml/2006/main">
             <a:pPr algn="l">
+              <a:buNone/>
               <a:defRPr sz="1875" b="1">
                 <a:solidFill>
                   <a:srgbClr val="B43CFF"/>
@@ -6771,6 +6840,7 @@
           <a:lstStyle xmlns:a="http://schemas.openxmlformats.org/drawingml/2006/main"/>
           <a:p xmlns:a="http://schemas.openxmlformats.org/drawingml/2006/main">
             <a:pPr algn="l">
+              <a:buNone/>
               <a:defRPr sz="1425" b="0">
                 <a:solidFill>
                   <a:srgbClr val="A8B4CC"/>
@@ -6917,6 +6987,7 @@
           <a:lstStyle xmlns:a="http://schemas.openxmlformats.org/drawingml/2006/main"/>
           <a:p xmlns:a="http://schemas.openxmlformats.org/drawingml/2006/main">
             <a:pPr algn="l">
+              <a:buNone/>
               <a:defRPr sz="1350" b="1">
                 <a:solidFill>
                   <a:srgbClr val="1BB7D1"/>
@@ -6974,6 +7045,7 @@
           <a:lstStyle xmlns:a="http://schemas.openxmlformats.org/drawingml/2006/main"/>
           <a:p xmlns:a="http://schemas.openxmlformats.org/drawingml/2006/main">
             <a:pPr algn="l">
+              <a:buNone/>
               <a:defRPr sz="3300" b="1">
                 <a:solidFill>
                   <a:srgbClr val="F8FAFC"/>
@@ -7031,6 +7103,7 @@
           <a:lstStyle xmlns:a="http://schemas.openxmlformats.org/drawingml/2006/main"/>
           <a:p xmlns:a="http://schemas.openxmlformats.org/drawingml/2006/main">
             <a:pPr algn="l">
+              <a:buNone/>
               <a:defRPr sz="1575" b="0">
                 <a:solidFill>
                   <a:srgbClr val="A8B4CC"/>
@@ -7088,6 +7161,7 @@
           <a:lstStyle xmlns:a="http://schemas.openxmlformats.org/drawingml/2006/main"/>
           <a:p xmlns:a="http://schemas.openxmlformats.org/drawingml/2006/main">
             <a:pPr algn="l">
+              <a:buNone/>
               <a:defRPr sz="1125" b="1">
                 <a:solidFill>
                   <a:srgbClr val="A8B4CC"/>
@@ -7145,6 +7219,7 @@
           <a:lstStyle xmlns:a="http://schemas.openxmlformats.org/drawingml/2006/main"/>
           <a:p xmlns:a="http://schemas.openxmlformats.org/drawingml/2006/main">
             <a:pPr algn="r">
+              <a:buNone/>
               <a:defRPr sz="1125" b="0">
                 <a:solidFill>
                   <a:srgbClr val="A8B4CC"/>
@@ -7202,6 +7277,7 @@
           <a:lstStyle xmlns:a="http://schemas.openxmlformats.org/drawingml/2006/main"/>
           <a:p xmlns:a="http://schemas.openxmlformats.org/drawingml/2006/main">
             <a:pPr algn="l">
+              <a:buNone/>
               <a:defRPr sz="2175" b="1">
                 <a:solidFill>
                   <a:srgbClr val="1BB7D1"/>
@@ -7259,6 +7335,7 @@
           <a:lstStyle xmlns:a="http://schemas.openxmlformats.org/drawingml/2006/main"/>
           <a:p xmlns:a="http://schemas.openxmlformats.org/drawingml/2006/main">
             <a:pPr algn="l">
+              <a:buNone/>
               <a:defRPr sz="1875" b="1">
                 <a:solidFill>
                   <a:srgbClr val="F8FAFC"/>
@@ -7316,6 +7393,7 @@
           <a:lstStyle xmlns:a="http://schemas.openxmlformats.org/drawingml/2006/main"/>
           <a:p xmlns:a="http://schemas.openxmlformats.org/drawingml/2006/main">
             <a:pPr algn="l">
+              <a:buNone/>
               <a:defRPr sz="2175" b="1">
                 <a:solidFill>
                   <a:srgbClr val="1BB7D1"/>
@@ -7373,6 +7451,7 @@
           <a:lstStyle xmlns:a="http://schemas.openxmlformats.org/drawingml/2006/main"/>
           <a:p xmlns:a="http://schemas.openxmlformats.org/drawingml/2006/main">
             <a:pPr algn="l">
+              <a:buNone/>
               <a:defRPr sz="1875" b="1">
                 <a:solidFill>
                   <a:srgbClr val="F8FAFC"/>
@@ -7430,6 +7509,7 @@
           <a:lstStyle xmlns:a="http://schemas.openxmlformats.org/drawingml/2006/main"/>
           <a:p xmlns:a="http://schemas.openxmlformats.org/drawingml/2006/main">
             <a:pPr algn="l">
+              <a:buNone/>
               <a:defRPr sz="2175" b="1">
                 <a:solidFill>
                   <a:srgbClr val="1BB7D1"/>
@@ -7487,6 +7567,7 @@
           <a:lstStyle xmlns:a="http://schemas.openxmlformats.org/drawingml/2006/main"/>
           <a:p xmlns:a="http://schemas.openxmlformats.org/drawingml/2006/main">
             <a:pPr algn="l">
+              <a:buNone/>
               <a:defRPr sz="1875" b="1">
                 <a:solidFill>
                   <a:srgbClr val="F8FAFC"/>
@@ -7544,6 +7625,7 @@
           <a:lstStyle xmlns:a="http://schemas.openxmlformats.org/drawingml/2006/main"/>
           <a:p xmlns:a="http://schemas.openxmlformats.org/drawingml/2006/main">
             <a:pPr algn="l">
+              <a:buNone/>
               <a:defRPr sz="1575" b="0">
                 <a:solidFill>
                   <a:srgbClr val="A8B4CC"/>
@@ -7569,25 +7651,23 @@
       </p:sp>
       <p:pic>
         <p:nvPicPr>
-          <p:cNvPr id="30" name=""/>
+          <p:cNvPr id="32" name=""/>
           <p:cNvPicPr>
             <a:picLocks xmlns:a="http://schemas.openxmlformats.org/drawingml/2006/main" noChangeAspect="1"/>
           </p:cNvPicPr>
           <p:nvPr/>
         </p:nvPicPr>
         <p:blipFill>
-          <a:blip xmlns:r="http://schemas.openxmlformats.org/officeDocument/2006/relationships" xmlns:a="http://schemas.openxmlformats.org/drawingml/2006/main" r:embed="R5a869daa746c4913"/>
+          <a:blip xmlns:r="http://schemas.openxmlformats.org/officeDocument/2006/relationships" xmlns:a="http://schemas.openxmlformats.org/drawingml/2006/main" r:embed="R5a9fee14724d4a57"/>
           <a:stretch xmlns:a="http://schemas.openxmlformats.org/drawingml/2006/main"/>
         </p:blipFill>
         <p:spPr>
-          <a:xfrm xmlns:a="http://schemas.openxmlformats.org/drawingml/2006/main">
+          <a:xfrm xmlns:a="http://schemas.openxmlformats.org/drawingml/2006/main" flipH="0" flipV="0">
             <a:off x="4552950" y="2059186"/>
             <a:ext cx="6953250" cy="3911203"/>
           </a:xfrm>
           <a:prstGeom xmlns:a="http://schemas.openxmlformats.org/drawingml/2006/main" prst="roundRect">
-            <a:avLst>
-              <a:gd name="adj" fmla="val 2920"/>
-            </a:avLst>
+            <a:avLst/>
           </a:prstGeom>
         </p:spPr>
       </p:pic>
@@ -7714,6 +7794,7 @@
           <a:lstStyle xmlns:a="http://schemas.openxmlformats.org/drawingml/2006/main"/>
           <a:p xmlns:a="http://schemas.openxmlformats.org/drawingml/2006/main">
             <a:pPr algn="l">
+              <a:buNone/>
               <a:defRPr sz="1350" b="1">
                 <a:solidFill>
                   <a:srgbClr val="1BB7D1"/>
@@ -7771,6 +7852,7 @@
           <a:lstStyle xmlns:a="http://schemas.openxmlformats.org/drawingml/2006/main"/>
           <a:p xmlns:a="http://schemas.openxmlformats.org/drawingml/2006/main">
             <a:pPr algn="l">
+              <a:buNone/>
               <a:defRPr sz="3300" b="1">
                 <a:solidFill>
                   <a:srgbClr val="F8FAFC"/>
@@ -7828,6 +7910,7 @@
           <a:lstStyle xmlns:a="http://schemas.openxmlformats.org/drawingml/2006/main"/>
           <a:p xmlns:a="http://schemas.openxmlformats.org/drawingml/2006/main">
             <a:pPr algn="l">
+              <a:buNone/>
               <a:defRPr sz="1125" b="1">
                 <a:solidFill>
                   <a:srgbClr val="A8B4CC"/>
@@ -7885,6 +7968,7 @@
           <a:lstStyle xmlns:a="http://schemas.openxmlformats.org/drawingml/2006/main"/>
           <a:p xmlns:a="http://schemas.openxmlformats.org/drawingml/2006/main">
             <a:pPr algn="r">
+              <a:buNone/>
               <a:defRPr sz="1125" b="0">
                 <a:solidFill>
                   <a:srgbClr val="A8B4CC"/>
@@ -7942,6 +8026,7 @@
           <a:lstStyle xmlns:a="http://schemas.openxmlformats.org/drawingml/2006/main"/>
           <a:p xmlns:a="http://schemas.openxmlformats.org/drawingml/2006/main">
             <a:pPr algn="l">
+              <a:buNone/>
               <a:defRPr sz="2700" b="1">
                 <a:solidFill>
                   <a:srgbClr val="B43CFF"/>
@@ -7999,6 +8084,7 @@
           <a:lstStyle xmlns:a="http://schemas.openxmlformats.org/drawingml/2006/main"/>
           <a:p xmlns:a="http://schemas.openxmlformats.org/drawingml/2006/main">
             <a:pPr algn="l">
+              <a:buNone/>
               <a:defRPr sz="1725" b="0">
                 <a:solidFill>
                   <a:srgbClr val="A8B4CC"/>
@@ -8056,6 +8142,7 @@
           <a:lstStyle xmlns:a="http://schemas.openxmlformats.org/drawingml/2006/main"/>
           <a:p xmlns:a="http://schemas.openxmlformats.org/drawingml/2006/main">
             <a:pPr algn="l">
+              <a:buNone/>
               <a:defRPr sz="2700" b="1">
                 <a:solidFill>
                   <a:srgbClr val="39D98A"/>
@@ -8113,6 +8200,7 @@
           <a:lstStyle xmlns:a="http://schemas.openxmlformats.org/drawingml/2006/main"/>
           <a:p xmlns:a="http://schemas.openxmlformats.org/drawingml/2006/main">
             <a:pPr algn="l">
+              <a:buNone/>
               <a:defRPr sz="1725" b="0">
                 <a:solidFill>
                   <a:srgbClr val="A8B4CC"/>
@@ -8200,6 +8288,7 @@
           <a:lstStyle xmlns:a="http://schemas.openxmlformats.org/drawingml/2006/main"/>
           <a:p xmlns:a="http://schemas.openxmlformats.org/drawingml/2006/main">
             <a:pPr algn="l">
+              <a:buNone/>
               <a:defRPr sz="2550" b="1">
                 <a:solidFill>
                   <a:srgbClr val="F8FAFC"/>
@@ -8426,6 +8515,7 @@
           <a:lstStyle xmlns:a="http://schemas.openxmlformats.org/drawingml/2006/main"/>
           <a:p xmlns:a="http://schemas.openxmlformats.org/drawingml/2006/main">
             <a:pPr algn="l">
+              <a:buNone/>
               <a:defRPr sz="1500" b="1">
                 <a:solidFill>
                   <a:srgbClr val="FBBF24"/>
@@ -8572,6 +8662,7 @@
           <a:lstStyle xmlns:a="http://schemas.openxmlformats.org/drawingml/2006/main"/>
           <a:p xmlns:a="http://schemas.openxmlformats.org/drawingml/2006/main">
             <a:pPr algn="l">
+              <a:buNone/>
               <a:defRPr sz="1350" b="1">
                 <a:solidFill>
                   <a:srgbClr val="1BB7D1"/>
@@ -8629,6 +8720,7 @@
           <a:lstStyle xmlns:a="http://schemas.openxmlformats.org/drawingml/2006/main"/>
           <a:p xmlns:a="http://schemas.openxmlformats.org/drawingml/2006/main">
             <a:pPr algn="l">
+              <a:buNone/>
               <a:defRPr sz="3300" b="1">
                 <a:solidFill>
                   <a:srgbClr val="F8FAFC"/>
@@ -8686,6 +8778,7 @@
           <a:lstStyle xmlns:a="http://schemas.openxmlformats.org/drawingml/2006/main"/>
           <a:p xmlns:a="http://schemas.openxmlformats.org/drawingml/2006/main">
             <a:pPr algn="l">
+              <a:buNone/>
               <a:defRPr sz="1125" b="1">
                 <a:solidFill>
                   <a:srgbClr val="A8B4CC"/>
@@ -8743,6 +8836,7 @@
           <a:lstStyle xmlns:a="http://schemas.openxmlformats.org/drawingml/2006/main"/>
           <a:p xmlns:a="http://schemas.openxmlformats.org/drawingml/2006/main">
             <a:pPr algn="r">
+              <a:buNone/>
               <a:defRPr sz="1125" b="0">
                 <a:solidFill>
                   <a:srgbClr val="A8B4CC"/>
@@ -8800,6 +8894,7 @@
           <a:lstStyle xmlns:a="http://schemas.openxmlformats.org/drawingml/2006/main"/>
           <a:p xmlns:a="http://schemas.openxmlformats.org/drawingml/2006/main">
             <a:pPr algn="l">
+              <a:buNone/>
               <a:defRPr sz="1275" b="1">
                 <a:solidFill>
                   <a:srgbClr val="1BB7D1"/>
@@ -8857,6 +8952,7 @@
           <a:lstStyle xmlns:a="http://schemas.openxmlformats.org/drawingml/2006/main"/>
           <a:p xmlns:a="http://schemas.openxmlformats.org/drawingml/2006/main">
             <a:pPr algn="l">
+              <a:buNone/>
               <a:defRPr sz="1725" b="0">
                 <a:solidFill>
                   <a:srgbClr val="F8FAFC"/>
@@ -8944,6 +9040,7 @@
           <a:lstStyle xmlns:a="http://schemas.openxmlformats.org/drawingml/2006/main"/>
           <a:p xmlns:a="http://schemas.openxmlformats.org/drawingml/2006/main">
             <a:pPr algn="l">
+              <a:buNone/>
               <a:defRPr sz="1275" b="1">
                 <a:solidFill>
                   <a:srgbClr val="1BB7D1"/>
@@ -9001,6 +9098,7 @@
           <a:lstStyle xmlns:a="http://schemas.openxmlformats.org/drawingml/2006/main"/>
           <a:p xmlns:a="http://schemas.openxmlformats.org/drawingml/2006/main">
             <a:pPr algn="l">
+              <a:buNone/>
               <a:defRPr sz="1725" b="0">
                 <a:solidFill>
                   <a:srgbClr val="F8FAFC"/>
@@ -9088,6 +9186,7 @@
           <a:lstStyle xmlns:a="http://schemas.openxmlformats.org/drawingml/2006/main"/>
           <a:p xmlns:a="http://schemas.openxmlformats.org/drawingml/2006/main">
             <a:pPr algn="l">
+              <a:buNone/>
               <a:defRPr sz="1275" b="1">
                 <a:solidFill>
                   <a:srgbClr val="1BB7D1"/>
@@ -9145,6 +9244,7 @@
           <a:lstStyle xmlns:a="http://schemas.openxmlformats.org/drawingml/2006/main"/>
           <a:p xmlns:a="http://schemas.openxmlformats.org/drawingml/2006/main">
             <a:pPr algn="l">
+              <a:buNone/>
               <a:defRPr sz="1725" b="0">
                 <a:solidFill>
                   <a:srgbClr val="F8FAFC"/>
@@ -9232,6 +9332,7 @@
           <a:lstStyle xmlns:a="http://schemas.openxmlformats.org/drawingml/2006/main"/>
           <a:p xmlns:a="http://schemas.openxmlformats.org/drawingml/2006/main">
             <a:pPr algn="l">
+              <a:buNone/>
               <a:defRPr sz="1275" b="1">
                 <a:solidFill>
                   <a:srgbClr val="1BB7D1"/>
@@ -9289,6 +9390,7 @@
           <a:lstStyle xmlns:a="http://schemas.openxmlformats.org/drawingml/2006/main"/>
           <a:p xmlns:a="http://schemas.openxmlformats.org/drawingml/2006/main">
             <a:pPr algn="l">
+              <a:buNone/>
               <a:defRPr sz="1725" b="0">
                 <a:solidFill>
                   <a:srgbClr val="F8FAFC"/>
@@ -9410,6 +9512,7 @@
           <a:lstStyle xmlns:a="http://schemas.openxmlformats.org/drawingml/2006/main"/>
           <a:p xmlns:a="http://schemas.openxmlformats.org/drawingml/2006/main">
             <a:pPr algn="ctr">
+              <a:buNone/>
               <a:defRPr sz="2325" b="1">
                 <a:solidFill>
                   <a:srgbClr val="FBBF24"/>
@@ -9467,6 +9570,7 @@
           <a:lstStyle xmlns:a="http://schemas.openxmlformats.org/drawingml/2006/main"/>
           <a:p xmlns:a="http://schemas.openxmlformats.org/drawingml/2006/main">
             <a:pPr algn="ctr">
+              <a:buNone/>
               <a:defRPr sz="1650" b="0">
                 <a:solidFill>
                   <a:srgbClr val="F8FAFC"/>
@@ -9524,6 +9628,7 @@
           <a:lstStyle xmlns:a="http://schemas.openxmlformats.org/drawingml/2006/main"/>
           <a:p xmlns:a="http://schemas.openxmlformats.org/drawingml/2006/main">
             <a:pPr algn="ctr">
+              <a:buNone/>
               <a:defRPr sz="1425" b="1">
                 <a:solidFill>
                   <a:srgbClr val="39D98A"/>
@@ -9670,6 +9775,7 @@
           <a:lstStyle xmlns:a="http://schemas.openxmlformats.org/drawingml/2006/main"/>
           <a:p xmlns:a="http://schemas.openxmlformats.org/drawingml/2006/main">
             <a:pPr algn="l">
+              <a:buNone/>
               <a:defRPr sz="1350" b="1">
                 <a:solidFill>
                   <a:srgbClr val="1BB7D1"/>
@@ -9727,6 +9833,7 @@
           <a:lstStyle xmlns:a="http://schemas.openxmlformats.org/drawingml/2006/main"/>
           <a:p xmlns:a="http://schemas.openxmlformats.org/drawingml/2006/main">
             <a:pPr algn="l">
+              <a:buNone/>
               <a:defRPr sz="3300" b="1">
                 <a:solidFill>
                   <a:srgbClr val="F8FAFC"/>
@@ -9784,6 +9891,7 @@
           <a:lstStyle xmlns:a="http://schemas.openxmlformats.org/drawingml/2006/main"/>
           <a:p xmlns:a="http://schemas.openxmlformats.org/drawingml/2006/main">
             <a:pPr algn="l">
+              <a:buNone/>
               <a:defRPr sz="1575" b="0">
                 <a:solidFill>
                   <a:srgbClr val="A8B4CC"/>
@@ -9841,6 +9949,7 @@
           <a:lstStyle xmlns:a="http://schemas.openxmlformats.org/drawingml/2006/main"/>
           <a:p xmlns:a="http://schemas.openxmlformats.org/drawingml/2006/main">
             <a:pPr algn="l">
+              <a:buNone/>
               <a:defRPr sz="1125" b="1">
                 <a:solidFill>
                   <a:srgbClr val="A8B4CC"/>
@@ -9898,6 +10007,7 @@
           <a:lstStyle xmlns:a="http://schemas.openxmlformats.org/drawingml/2006/main"/>
           <a:p xmlns:a="http://schemas.openxmlformats.org/drawingml/2006/main">
             <a:pPr algn="r">
+              <a:buNone/>
               <a:defRPr sz="1125" b="0">
                 <a:solidFill>
                   <a:srgbClr val="A8B4CC"/>
@@ -9955,6 +10065,7 @@
           <a:lstStyle xmlns:a="http://schemas.openxmlformats.org/drawingml/2006/main"/>
           <a:p xmlns:a="http://schemas.openxmlformats.org/drawingml/2006/main">
             <a:pPr algn="l">
+              <a:buNone/>
               <a:defRPr sz="2100" b="1">
                 <a:solidFill>
                   <a:srgbClr val="1BB7D1"/>
@@ -10012,6 +10123,7 @@
           <a:lstStyle xmlns:a="http://schemas.openxmlformats.org/drawingml/2006/main"/>
           <a:p xmlns:a="http://schemas.openxmlformats.org/drawingml/2006/main">
             <a:pPr algn="l">
+              <a:buNone/>
               <a:defRPr sz="1875" b="0">
                 <a:solidFill>
                   <a:srgbClr val="F8FAFC"/>
@@ -10099,6 +10211,7 @@
           <a:lstStyle xmlns:a="http://schemas.openxmlformats.org/drawingml/2006/main"/>
           <a:p xmlns:a="http://schemas.openxmlformats.org/drawingml/2006/main">
             <a:pPr algn="l">
+              <a:buNone/>
               <a:defRPr sz="2100" b="1">
                 <a:solidFill>
                   <a:srgbClr val="1BB7D1"/>
@@ -10156,6 +10269,7 @@
           <a:lstStyle xmlns:a="http://schemas.openxmlformats.org/drawingml/2006/main"/>
           <a:p xmlns:a="http://schemas.openxmlformats.org/drawingml/2006/main">
             <a:pPr algn="l">
+              <a:buNone/>
               <a:defRPr sz="1875" b="0">
                 <a:solidFill>
                   <a:srgbClr val="F8FAFC"/>
@@ -10243,6 +10357,7 @@
           <a:lstStyle xmlns:a="http://schemas.openxmlformats.org/drawingml/2006/main"/>
           <a:p xmlns:a="http://schemas.openxmlformats.org/drawingml/2006/main">
             <a:pPr algn="l">
+              <a:buNone/>
               <a:defRPr sz="2100" b="1">
                 <a:solidFill>
                   <a:srgbClr val="1BB7D1"/>
@@ -10300,6 +10415,7 @@
           <a:lstStyle xmlns:a="http://schemas.openxmlformats.org/drawingml/2006/main"/>
           <a:p xmlns:a="http://schemas.openxmlformats.org/drawingml/2006/main">
             <a:pPr algn="l">
+              <a:buNone/>
               <a:defRPr sz="1875" b="0">
                 <a:solidFill>
                   <a:srgbClr val="F8FAFC"/>
@@ -10387,6 +10503,7 @@
           <a:lstStyle xmlns:a="http://schemas.openxmlformats.org/drawingml/2006/main"/>
           <a:p xmlns:a="http://schemas.openxmlformats.org/drawingml/2006/main">
             <a:pPr algn="l">
+              <a:buNone/>
               <a:defRPr sz="2100" b="1">
                 <a:solidFill>
                   <a:srgbClr val="1BB7D1"/>
@@ -10444,6 +10561,7 @@
           <a:lstStyle xmlns:a="http://schemas.openxmlformats.org/drawingml/2006/main"/>
           <a:p xmlns:a="http://schemas.openxmlformats.org/drawingml/2006/main">
             <a:pPr algn="l">
+              <a:buNone/>
               <a:defRPr sz="1875" b="0">
                 <a:solidFill>
                   <a:srgbClr val="F8FAFC"/>
@@ -10531,6 +10649,7 @@
           <a:lstStyle xmlns:a="http://schemas.openxmlformats.org/drawingml/2006/main"/>
           <a:p xmlns:a="http://schemas.openxmlformats.org/drawingml/2006/main">
             <a:pPr algn="l">
+              <a:buNone/>
               <a:defRPr sz="2100" b="1">
                 <a:solidFill>
                   <a:srgbClr val="B43CFF"/>
@@ -10588,6 +10707,7 @@
           <a:lstStyle xmlns:a="http://schemas.openxmlformats.org/drawingml/2006/main"/>
           <a:p xmlns:a="http://schemas.openxmlformats.org/drawingml/2006/main">
             <a:pPr algn="l">
+              <a:buNone/>
               <a:defRPr sz="1875" b="0">
                 <a:solidFill>
                   <a:srgbClr val="F8FAFC"/>

</xml_diff>